<commit_message>
Expand concept motivation slide text
</commit_message>
<xml_diff>
--- a/output/slide5_concept_motivation.pptx
+++ b/output/slide5_concept_motivation.pptx
@@ -129,7 +129,7 @@
           <p:cNvPr id="2" name="標題 1">
             <a:extLst>
               <a:ext uri="{FF2B5EF4-FFF2-40B4-BE49-F238E27FC236}">
-                <a16:creationId xmlns:a16="http://schemas.microsoft.com/office/drawing/2014/main" id="{4BA1493D-B92E-2D0E-0977-949849A17817}"/>
+                <a16:creationId xmlns:a16="http://schemas.microsoft.com/office/drawing/2014/main" id="{8A4C84BB-2F9A-7F16-8415-8F08DFEC4812}"/>
               </a:ext>
             </a:extLst>
           </p:cNvPr>
@@ -166,7 +166,7 @@
           <p:cNvPr id="3" name="副標題 2">
             <a:extLst>
               <a:ext uri="{FF2B5EF4-FFF2-40B4-BE49-F238E27FC236}">
-                <a16:creationId xmlns:a16="http://schemas.microsoft.com/office/drawing/2014/main" id="{C54EB312-EC8A-68BC-FE2A-49626C7C2449}"/>
+                <a16:creationId xmlns:a16="http://schemas.microsoft.com/office/drawing/2014/main" id="{4681F04A-1FA3-3C3D-8065-0974FD1474A1}"/>
               </a:ext>
             </a:extLst>
           </p:cNvPr>
@@ -236,7 +236,7 @@
           <p:cNvPr id="4" name="日期版面配置區 3">
             <a:extLst>
               <a:ext uri="{FF2B5EF4-FFF2-40B4-BE49-F238E27FC236}">
-                <a16:creationId xmlns:a16="http://schemas.microsoft.com/office/drawing/2014/main" id="{AE83AC03-2790-4EE8-4259-D7FA08A143B9}"/>
+                <a16:creationId xmlns:a16="http://schemas.microsoft.com/office/drawing/2014/main" id="{927D6305-7F70-A3A7-CB83-8E2BABF2E818}"/>
               </a:ext>
             </a:extLst>
           </p:cNvPr>
@@ -252,7 +252,7 @@
           <a:bodyPr/>
           <a:lstStyle/>
           <a:p>
-            <a:fld id="{49A4FC28-A91B-426C-8314-47BE114A8C69}" type="datetimeFigureOut">
+            <a:fld id="{1C769F6A-7DA7-4601-8260-93A464B264CF}" type="datetimeFigureOut">
               <a:rPr lang="zh-TW" altLang="en-US" smtClean="0"/>
               <a:t>2026/5/25</a:t>
             </a:fld>
@@ -265,7 +265,7 @@
           <p:cNvPr id="5" name="頁尾版面配置區 4">
             <a:extLst>
               <a:ext uri="{FF2B5EF4-FFF2-40B4-BE49-F238E27FC236}">
-                <a16:creationId xmlns:a16="http://schemas.microsoft.com/office/drawing/2014/main" id="{1DF13DB9-3BEC-63A4-86DD-CFA44354836C}"/>
+                <a16:creationId xmlns:a16="http://schemas.microsoft.com/office/drawing/2014/main" id="{68B09B17-3204-B134-B699-DC26AEBC830B}"/>
               </a:ext>
             </a:extLst>
           </p:cNvPr>
@@ -290,7 +290,7 @@
           <p:cNvPr id="6" name="投影片編號版面配置區 5">
             <a:extLst>
               <a:ext uri="{FF2B5EF4-FFF2-40B4-BE49-F238E27FC236}">
-                <a16:creationId xmlns:a16="http://schemas.microsoft.com/office/drawing/2014/main" id="{AA9E24FC-D34B-2188-3357-74EB149F092D}"/>
+                <a16:creationId xmlns:a16="http://schemas.microsoft.com/office/drawing/2014/main" id="{18639538-BF75-4EB0-62BF-18200AE192AE}"/>
               </a:ext>
             </a:extLst>
           </p:cNvPr>
@@ -306,7 +306,7 @@
           <a:bodyPr/>
           <a:lstStyle/>
           <a:p>
-            <a:fld id="{24E37152-1061-4887-A133-42AB91A9FA6A}" type="slidenum">
+            <a:fld id="{D34EAC9D-8C0A-4F5D-938E-826571E3FC8C}" type="slidenum">
               <a:rPr lang="zh-TW" altLang="en-US" smtClean="0"/>
               <a:t>‹#›</a:t>
             </a:fld>
@@ -317,7 +317,7 @@
     </p:spTree>
     <p:extLst>
       <p:ext uri="{BB962C8B-B14F-4D97-AF65-F5344CB8AC3E}">
-        <p14:creationId xmlns:p14="http://schemas.microsoft.com/office/powerpoint/2010/main" val="1082740970"/>
+        <p14:creationId xmlns:p14="http://schemas.microsoft.com/office/powerpoint/2010/main" val="3222099414"/>
       </p:ext>
     </p:extLst>
   </p:cSld>
@@ -349,7 +349,7 @@
           <p:cNvPr id="2" name="標題 1">
             <a:extLst>
               <a:ext uri="{FF2B5EF4-FFF2-40B4-BE49-F238E27FC236}">
-                <a16:creationId xmlns:a16="http://schemas.microsoft.com/office/drawing/2014/main" id="{D98E9E27-5460-9E48-3D81-65832C669262}"/>
+                <a16:creationId xmlns:a16="http://schemas.microsoft.com/office/drawing/2014/main" id="{E4F96AD2-D57B-6C77-FAA4-E9A68FB7EC54}"/>
               </a:ext>
             </a:extLst>
           </p:cNvPr>
@@ -377,7 +377,7 @@
           <p:cNvPr id="3" name="直排文字版面配置區 2">
             <a:extLst>
               <a:ext uri="{FF2B5EF4-FFF2-40B4-BE49-F238E27FC236}">
-                <a16:creationId xmlns:a16="http://schemas.microsoft.com/office/drawing/2014/main" id="{D364CA76-80DA-3E62-F174-42F71CB93C53}"/>
+                <a16:creationId xmlns:a16="http://schemas.microsoft.com/office/drawing/2014/main" id="{B6EA5071-6D75-5015-8B74-116EB7B2ADEB}"/>
               </a:ext>
             </a:extLst>
           </p:cNvPr>
@@ -434,7 +434,7 @@
           <p:cNvPr id="4" name="日期版面配置區 3">
             <a:extLst>
               <a:ext uri="{FF2B5EF4-FFF2-40B4-BE49-F238E27FC236}">
-                <a16:creationId xmlns:a16="http://schemas.microsoft.com/office/drawing/2014/main" id="{54BCFEC1-F5F2-8B4D-A04E-7BC463AF3783}"/>
+                <a16:creationId xmlns:a16="http://schemas.microsoft.com/office/drawing/2014/main" id="{88A43A2A-A813-34C4-4B9B-EC3668E80980}"/>
               </a:ext>
             </a:extLst>
           </p:cNvPr>
@@ -450,7 +450,7 @@
           <a:bodyPr/>
           <a:lstStyle/>
           <a:p>
-            <a:fld id="{49A4FC28-A91B-426C-8314-47BE114A8C69}" type="datetimeFigureOut">
+            <a:fld id="{1C769F6A-7DA7-4601-8260-93A464B264CF}" type="datetimeFigureOut">
               <a:rPr lang="zh-TW" altLang="en-US" smtClean="0"/>
               <a:t>2026/5/25</a:t>
             </a:fld>
@@ -463,7 +463,7 @@
           <p:cNvPr id="5" name="頁尾版面配置區 4">
             <a:extLst>
               <a:ext uri="{FF2B5EF4-FFF2-40B4-BE49-F238E27FC236}">
-                <a16:creationId xmlns:a16="http://schemas.microsoft.com/office/drawing/2014/main" id="{21A46EF5-FE26-84A6-A86F-B02662549A1E}"/>
+                <a16:creationId xmlns:a16="http://schemas.microsoft.com/office/drawing/2014/main" id="{70B90791-E00E-3E89-82D8-FD39F9DF93FF}"/>
               </a:ext>
             </a:extLst>
           </p:cNvPr>
@@ -488,7 +488,7 @@
           <p:cNvPr id="6" name="投影片編號版面配置區 5">
             <a:extLst>
               <a:ext uri="{FF2B5EF4-FFF2-40B4-BE49-F238E27FC236}">
-                <a16:creationId xmlns:a16="http://schemas.microsoft.com/office/drawing/2014/main" id="{5B6D1BB5-DB00-66F9-EB2B-D8DF27388554}"/>
+                <a16:creationId xmlns:a16="http://schemas.microsoft.com/office/drawing/2014/main" id="{CD8F34AE-3BCB-38DD-62A4-23C4DC218A39}"/>
               </a:ext>
             </a:extLst>
           </p:cNvPr>
@@ -504,7 +504,7 @@
           <a:bodyPr/>
           <a:lstStyle/>
           <a:p>
-            <a:fld id="{24E37152-1061-4887-A133-42AB91A9FA6A}" type="slidenum">
+            <a:fld id="{D34EAC9D-8C0A-4F5D-938E-826571E3FC8C}" type="slidenum">
               <a:rPr lang="zh-TW" altLang="en-US" smtClean="0"/>
               <a:t>‹#›</a:t>
             </a:fld>
@@ -515,7 +515,7 @@
     </p:spTree>
     <p:extLst>
       <p:ext uri="{BB962C8B-B14F-4D97-AF65-F5344CB8AC3E}">
-        <p14:creationId xmlns:p14="http://schemas.microsoft.com/office/powerpoint/2010/main" val="502154904"/>
+        <p14:creationId xmlns:p14="http://schemas.microsoft.com/office/powerpoint/2010/main" val="715768148"/>
       </p:ext>
     </p:extLst>
   </p:cSld>
@@ -547,7 +547,7 @@
           <p:cNvPr id="2" name="直排標題 1">
             <a:extLst>
               <a:ext uri="{FF2B5EF4-FFF2-40B4-BE49-F238E27FC236}">
-                <a16:creationId xmlns:a16="http://schemas.microsoft.com/office/drawing/2014/main" id="{34118182-C7F2-4402-E639-AFBCF89AB30F}"/>
+                <a16:creationId xmlns:a16="http://schemas.microsoft.com/office/drawing/2014/main" id="{C19768B7-68F8-0951-AB6F-9F6CB54AC7FA}"/>
               </a:ext>
             </a:extLst>
           </p:cNvPr>
@@ -580,7 +580,7 @@
           <p:cNvPr id="3" name="直排文字版面配置區 2">
             <a:extLst>
               <a:ext uri="{FF2B5EF4-FFF2-40B4-BE49-F238E27FC236}">
-                <a16:creationId xmlns:a16="http://schemas.microsoft.com/office/drawing/2014/main" id="{004005CD-05FD-9CE7-10C1-4FDA6D3C770C}"/>
+                <a16:creationId xmlns:a16="http://schemas.microsoft.com/office/drawing/2014/main" id="{E060C27C-C9CC-4DAA-4C65-4D4BD335C026}"/>
               </a:ext>
             </a:extLst>
           </p:cNvPr>
@@ -642,7 +642,7 @@
           <p:cNvPr id="4" name="日期版面配置區 3">
             <a:extLst>
               <a:ext uri="{FF2B5EF4-FFF2-40B4-BE49-F238E27FC236}">
-                <a16:creationId xmlns:a16="http://schemas.microsoft.com/office/drawing/2014/main" id="{29B2123A-1FA5-E170-25F9-9F982F605BA7}"/>
+                <a16:creationId xmlns:a16="http://schemas.microsoft.com/office/drawing/2014/main" id="{0F715DE8-2B0B-A988-BB17-D543845A0347}"/>
               </a:ext>
             </a:extLst>
           </p:cNvPr>
@@ -658,7 +658,7 @@
           <a:bodyPr/>
           <a:lstStyle/>
           <a:p>
-            <a:fld id="{49A4FC28-A91B-426C-8314-47BE114A8C69}" type="datetimeFigureOut">
+            <a:fld id="{1C769F6A-7DA7-4601-8260-93A464B264CF}" type="datetimeFigureOut">
               <a:rPr lang="zh-TW" altLang="en-US" smtClean="0"/>
               <a:t>2026/5/25</a:t>
             </a:fld>
@@ -671,7 +671,7 @@
           <p:cNvPr id="5" name="頁尾版面配置區 4">
             <a:extLst>
               <a:ext uri="{FF2B5EF4-FFF2-40B4-BE49-F238E27FC236}">
-                <a16:creationId xmlns:a16="http://schemas.microsoft.com/office/drawing/2014/main" id="{D7F6B923-5A2B-4029-1DB4-B526527790D8}"/>
+                <a16:creationId xmlns:a16="http://schemas.microsoft.com/office/drawing/2014/main" id="{A3FAF510-522A-9362-1623-9989546DA21A}"/>
               </a:ext>
             </a:extLst>
           </p:cNvPr>
@@ -696,7 +696,7 @@
           <p:cNvPr id="6" name="投影片編號版面配置區 5">
             <a:extLst>
               <a:ext uri="{FF2B5EF4-FFF2-40B4-BE49-F238E27FC236}">
-                <a16:creationId xmlns:a16="http://schemas.microsoft.com/office/drawing/2014/main" id="{4C56838D-6B73-DB7D-DF2A-4944D0DFBFA1}"/>
+                <a16:creationId xmlns:a16="http://schemas.microsoft.com/office/drawing/2014/main" id="{DD3B6039-D8F0-58BA-AEA4-02B8E36F3B0B}"/>
               </a:ext>
             </a:extLst>
           </p:cNvPr>
@@ -712,7 +712,7 @@
           <a:bodyPr/>
           <a:lstStyle/>
           <a:p>
-            <a:fld id="{24E37152-1061-4887-A133-42AB91A9FA6A}" type="slidenum">
+            <a:fld id="{D34EAC9D-8C0A-4F5D-938E-826571E3FC8C}" type="slidenum">
               <a:rPr lang="zh-TW" altLang="en-US" smtClean="0"/>
               <a:t>‹#›</a:t>
             </a:fld>
@@ -723,7 +723,7 @@
     </p:spTree>
     <p:extLst>
       <p:ext uri="{BB962C8B-B14F-4D97-AF65-F5344CB8AC3E}">
-        <p14:creationId xmlns:p14="http://schemas.microsoft.com/office/powerpoint/2010/main" val="1195126445"/>
+        <p14:creationId xmlns:p14="http://schemas.microsoft.com/office/powerpoint/2010/main" val="1506890872"/>
       </p:ext>
     </p:extLst>
   </p:cSld>
@@ -755,7 +755,7 @@
           <p:cNvPr id="2" name="標題 1">
             <a:extLst>
               <a:ext uri="{FF2B5EF4-FFF2-40B4-BE49-F238E27FC236}">
-                <a16:creationId xmlns:a16="http://schemas.microsoft.com/office/drawing/2014/main" id="{D0C62397-8B44-F46D-2490-034226C369E8}"/>
+                <a16:creationId xmlns:a16="http://schemas.microsoft.com/office/drawing/2014/main" id="{EB003935-641C-B65C-1B9D-761978423158}"/>
               </a:ext>
             </a:extLst>
           </p:cNvPr>
@@ -783,7 +783,7 @@
           <p:cNvPr id="3" name="內容版面配置區 2">
             <a:extLst>
               <a:ext uri="{FF2B5EF4-FFF2-40B4-BE49-F238E27FC236}">
-                <a16:creationId xmlns:a16="http://schemas.microsoft.com/office/drawing/2014/main" id="{78A86B2D-7A04-EA2F-D398-F8883A8D23BA}"/>
+                <a16:creationId xmlns:a16="http://schemas.microsoft.com/office/drawing/2014/main" id="{D91BE132-3D2C-E752-06B0-56B924EBF30E}"/>
               </a:ext>
             </a:extLst>
           </p:cNvPr>
@@ -840,7 +840,7 @@
           <p:cNvPr id="4" name="日期版面配置區 3">
             <a:extLst>
               <a:ext uri="{FF2B5EF4-FFF2-40B4-BE49-F238E27FC236}">
-                <a16:creationId xmlns:a16="http://schemas.microsoft.com/office/drawing/2014/main" id="{4BA60053-D830-436B-2CCB-D943C01B5AE7}"/>
+                <a16:creationId xmlns:a16="http://schemas.microsoft.com/office/drawing/2014/main" id="{C2600BCC-520B-82FC-06A8-4E0D3BDE515B}"/>
               </a:ext>
             </a:extLst>
           </p:cNvPr>
@@ -856,7 +856,7 @@
           <a:bodyPr/>
           <a:lstStyle/>
           <a:p>
-            <a:fld id="{49A4FC28-A91B-426C-8314-47BE114A8C69}" type="datetimeFigureOut">
+            <a:fld id="{1C769F6A-7DA7-4601-8260-93A464B264CF}" type="datetimeFigureOut">
               <a:rPr lang="zh-TW" altLang="en-US" smtClean="0"/>
               <a:t>2026/5/25</a:t>
             </a:fld>
@@ -869,7 +869,7 @@
           <p:cNvPr id="5" name="頁尾版面配置區 4">
             <a:extLst>
               <a:ext uri="{FF2B5EF4-FFF2-40B4-BE49-F238E27FC236}">
-                <a16:creationId xmlns:a16="http://schemas.microsoft.com/office/drawing/2014/main" id="{649DF000-D30C-A4A9-953B-5C85F35EA7D7}"/>
+                <a16:creationId xmlns:a16="http://schemas.microsoft.com/office/drawing/2014/main" id="{7953E4BE-6358-DCDC-FC81-2FB9218428E1}"/>
               </a:ext>
             </a:extLst>
           </p:cNvPr>
@@ -894,7 +894,7 @@
           <p:cNvPr id="6" name="投影片編號版面配置區 5">
             <a:extLst>
               <a:ext uri="{FF2B5EF4-FFF2-40B4-BE49-F238E27FC236}">
-                <a16:creationId xmlns:a16="http://schemas.microsoft.com/office/drawing/2014/main" id="{9EA1B80E-0C01-F546-821E-6D9E178FFC28}"/>
+                <a16:creationId xmlns:a16="http://schemas.microsoft.com/office/drawing/2014/main" id="{FF4A0F5B-C8AB-0156-6DEA-3243CC96AE5D}"/>
               </a:ext>
             </a:extLst>
           </p:cNvPr>
@@ -910,7 +910,7 @@
           <a:bodyPr/>
           <a:lstStyle/>
           <a:p>
-            <a:fld id="{24E37152-1061-4887-A133-42AB91A9FA6A}" type="slidenum">
+            <a:fld id="{D34EAC9D-8C0A-4F5D-938E-826571E3FC8C}" type="slidenum">
               <a:rPr lang="zh-TW" altLang="en-US" smtClean="0"/>
               <a:t>‹#›</a:t>
             </a:fld>
@@ -921,7 +921,7 @@
     </p:spTree>
     <p:extLst>
       <p:ext uri="{BB962C8B-B14F-4D97-AF65-F5344CB8AC3E}">
-        <p14:creationId xmlns:p14="http://schemas.microsoft.com/office/powerpoint/2010/main" val="3972766659"/>
+        <p14:creationId xmlns:p14="http://schemas.microsoft.com/office/powerpoint/2010/main" val="3818454299"/>
       </p:ext>
     </p:extLst>
   </p:cSld>
@@ -953,7 +953,7 @@
           <p:cNvPr id="2" name="標題 1">
             <a:extLst>
               <a:ext uri="{FF2B5EF4-FFF2-40B4-BE49-F238E27FC236}">
-                <a16:creationId xmlns:a16="http://schemas.microsoft.com/office/drawing/2014/main" id="{2960612D-28B5-AC15-961F-FF79384A8A5A}"/>
+                <a16:creationId xmlns:a16="http://schemas.microsoft.com/office/drawing/2014/main" id="{2D02A029-F055-59FB-78BA-67D1871DACB0}"/>
               </a:ext>
             </a:extLst>
           </p:cNvPr>
@@ -990,7 +990,7 @@
           <p:cNvPr id="3" name="文字版面配置區 2">
             <a:extLst>
               <a:ext uri="{FF2B5EF4-FFF2-40B4-BE49-F238E27FC236}">
-                <a16:creationId xmlns:a16="http://schemas.microsoft.com/office/drawing/2014/main" id="{AFBCA05C-4E5B-D111-D5AC-C174342937FF}"/>
+                <a16:creationId xmlns:a16="http://schemas.microsoft.com/office/drawing/2014/main" id="{3A5FFE68-36BC-8A0A-E768-AFF6164FE930}"/>
               </a:ext>
             </a:extLst>
           </p:cNvPr>
@@ -1115,7 +1115,7 @@
           <p:cNvPr id="4" name="日期版面配置區 3">
             <a:extLst>
               <a:ext uri="{FF2B5EF4-FFF2-40B4-BE49-F238E27FC236}">
-                <a16:creationId xmlns:a16="http://schemas.microsoft.com/office/drawing/2014/main" id="{E037DA1B-6D78-7F82-7BB1-D76D153A9F89}"/>
+                <a16:creationId xmlns:a16="http://schemas.microsoft.com/office/drawing/2014/main" id="{7316BF6A-CFF5-B0BF-4410-ACCCD9C7BEC1}"/>
               </a:ext>
             </a:extLst>
           </p:cNvPr>
@@ -1131,7 +1131,7 @@
           <a:bodyPr/>
           <a:lstStyle/>
           <a:p>
-            <a:fld id="{49A4FC28-A91B-426C-8314-47BE114A8C69}" type="datetimeFigureOut">
+            <a:fld id="{1C769F6A-7DA7-4601-8260-93A464B264CF}" type="datetimeFigureOut">
               <a:rPr lang="zh-TW" altLang="en-US" smtClean="0"/>
               <a:t>2026/5/25</a:t>
             </a:fld>
@@ -1144,7 +1144,7 @@
           <p:cNvPr id="5" name="頁尾版面配置區 4">
             <a:extLst>
               <a:ext uri="{FF2B5EF4-FFF2-40B4-BE49-F238E27FC236}">
-                <a16:creationId xmlns:a16="http://schemas.microsoft.com/office/drawing/2014/main" id="{A30B4B08-ABA1-86C1-72DA-D02087D35FFA}"/>
+                <a16:creationId xmlns:a16="http://schemas.microsoft.com/office/drawing/2014/main" id="{75E345E3-EC78-FA50-6406-C37A8729F89A}"/>
               </a:ext>
             </a:extLst>
           </p:cNvPr>
@@ -1169,7 +1169,7 @@
           <p:cNvPr id="6" name="投影片編號版面配置區 5">
             <a:extLst>
               <a:ext uri="{FF2B5EF4-FFF2-40B4-BE49-F238E27FC236}">
-                <a16:creationId xmlns:a16="http://schemas.microsoft.com/office/drawing/2014/main" id="{18D03CC3-CCA0-D14A-1A5A-CD16FA17B774}"/>
+                <a16:creationId xmlns:a16="http://schemas.microsoft.com/office/drawing/2014/main" id="{B5BD54CE-DE70-9703-FD9C-2C6801D94B5E}"/>
               </a:ext>
             </a:extLst>
           </p:cNvPr>
@@ -1185,7 +1185,7 @@
           <a:bodyPr/>
           <a:lstStyle/>
           <a:p>
-            <a:fld id="{24E37152-1061-4887-A133-42AB91A9FA6A}" type="slidenum">
+            <a:fld id="{D34EAC9D-8C0A-4F5D-938E-826571E3FC8C}" type="slidenum">
               <a:rPr lang="zh-TW" altLang="en-US" smtClean="0"/>
               <a:t>‹#›</a:t>
             </a:fld>
@@ -1196,7 +1196,7 @@
     </p:spTree>
     <p:extLst>
       <p:ext uri="{BB962C8B-B14F-4D97-AF65-F5344CB8AC3E}">
-        <p14:creationId xmlns:p14="http://schemas.microsoft.com/office/powerpoint/2010/main" val="4088273814"/>
+        <p14:creationId xmlns:p14="http://schemas.microsoft.com/office/powerpoint/2010/main" val="291070041"/>
       </p:ext>
     </p:extLst>
   </p:cSld>
@@ -1228,7 +1228,7 @@
           <p:cNvPr id="2" name="標題 1">
             <a:extLst>
               <a:ext uri="{FF2B5EF4-FFF2-40B4-BE49-F238E27FC236}">
-                <a16:creationId xmlns:a16="http://schemas.microsoft.com/office/drawing/2014/main" id="{B981BB6A-9CDA-23F5-5D73-A3AA6EC7425C}"/>
+                <a16:creationId xmlns:a16="http://schemas.microsoft.com/office/drawing/2014/main" id="{C9E50E11-70EB-4A61-4B76-5F7C99045786}"/>
               </a:ext>
             </a:extLst>
           </p:cNvPr>
@@ -1256,7 +1256,7 @@
           <p:cNvPr id="3" name="內容版面配置區 2">
             <a:extLst>
               <a:ext uri="{FF2B5EF4-FFF2-40B4-BE49-F238E27FC236}">
-                <a16:creationId xmlns:a16="http://schemas.microsoft.com/office/drawing/2014/main" id="{616DEF31-6249-1942-70D2-0FC6AD95BDF7}"/>
+                <a16:creationId xmlns:a16="http://schemas.microsoft.com/office/drawing/2014/main" id="{6F41719C-B21E-6F9C-3265-4275D614B132}"/>
               </a:ext>
             </a:extLst>
           </p:cNvPr>
@@ -1318,7 +1318,7 @@
           <p:cNvPr id="4" name="內容版面配置區 3">
             <a:extLst>
               <a:ext uri="{FF2B5EF4-FFF2-40B4-BE49-F238E27FC236}">
-                <a16:creationId xmlns:a16="http://schemas.microsoft.com/office/drawing/2014/main" id="{8A0F35F2-5449-0032-4A92-AAC6B623E083}"/>
+                <a16:creationId xmlns:a16="http://schemas.microsoft.com/office/drawing/2014/main" id="{5EB85435-5E4A-3F78-9BBA-2F020635B04D}"/>
               </a:ext>
             </a:extLst>
           </p:cNvPr>
@@ -1380,7 +1380,7 @@
           <p:cNvPr id="5" name="日期版面配置區 4">
             <a:extLst>
               <a:ext uri="{FF2B5EF4-FFF2-40B4-BE49-F238E27FC236}">
-                <a16:creationId xmlns:a16="http://schemas.microsoft.com/office/drawing/2014/main" id="{ED3B9D6F-04F2-59C3-BD21-CEE13FA1F066}"/>
+                <a16:creationId xmlns:a16="http://schemas.microsoft.com/office/drawing/2014/main" id="{B31F21BF-4A35-148A-8828-5C2E8435C300}"/>
               </a:ext>
             </a:extLst>
           </p:cNvPr>
@@ -1396,7 +1396,7 @@
           <a:bodyPr/>
           <a:lstStyle/>
           <a:p>
-            <a:fld id="{49A4FC28-A91B-426C-8314-47BE114A8C69}" type="datetimeFigureOut">
+            <a:fld id="{1C769F6A-7DA7-4601-8260-93A464B264CF}" type="datetimeFigureOut">
               <a:rPr lang="zh-TW" altLang="en-US" smtClean="0"/>
               <a:t>2026/5/25</a:t>
             </a:fld>
@@ -1409,7 +1409,7 @@
           <p:cNvPr id="6" name="頁尾版面配置區 5">
             <a:extLst>
               <a:ext uri="{FF2B5EF4-FFF2-40B4-BE49-F238E27FC236}">
-                <a16:creationId xmlns:a16="http://schemas.microsoft.com/office/drawing/2014/main" id="{E043447C-0CA5-08B6-CD10-5B5E976AE4C1}"/>
+                <a16:creationId xmlns:a16="http://schemas.microsoft.com/office/drawing/2014/main" id="{A8105A35-0C41-A419-1B3B-0B415F8180EB}"/>
               </a:ext>
             </a:extLst>
           </p:cNvPr>
@@ -1434,7 +1434,7 @@
           <p:cNvPr id="7" name="投影片編號版面配置區 6">
             <a:extLst>
               <a:ext uri="{FF2B5EF4-FFF2-40B4-BE49-F238E27FC236}">
-                <a16:creationId xmlns:a16="http://schemas.microsoft.com/office/drawing/2014/main" id="{721FB263-168E-5F3B-1E32-FC5D28966624}"/>
+                <a16:creationId xmlns:a16="http://schemas.microsoft.com/office/drawing/2014/main" id="{DCABFE59-7C42-0854-C0DB-693C76CC9693}"/>
               </a:ext>
             </a:extLst>
           </p:cNvPr>
@@ -1450,7 +1450,7 @@
           <a:bodyPr/>
           <a:lstStyle/>
           <a:p>
-            <a:fld id="{24E37152-1061-4887-A133-42AB91A9FA6A}" type="slidenum">
+            <a:fld id="{D34EAC9D-8C0A-4F5D-938E-826571E3FC8C}" type="slidenum">
               <a:rPr lang="zh-TW" altLang="en-US" smtClean="0"/>
               <a:t>‹#›</a:t>
             </a:fld>
@@ -1461,7 +1461,7 @@
     </p:spTree>
     <p:extLst>
       <p:ext uri="{BB962C8B-B14F-4D97-AF65-F5344CB8AC3E}">
-        <p14:creationId xmlns:p14="http://schemas.microsoft.com/office/powerpoint/2010/main" val="1118796992"/>
+        <p14:creationId xmlns:p14="http://schemas.microsoft.com/office/powerpoint/2010/main" val="2970865916"/>
       </p:ext>
     </p:extLst>
   </p:cSld>
@@ -1493,7 +1493,7 @@
           <p:cNvPr id="2" name="標題 1">
             <a:extLst>
               <a:ext uri="{FF2B5EF4-FFF2-40B4-BE49-F238E27FC236}">
-                <a16:creationId xmlns:a16="http://schemas.microsoft.com/office/drawing/2014/main" id="{46B8FBAC-7D91-D504-7E53-C861C8B477C4}"/>
+                <a16:creationId xmlns:a16="http://schemas.microsoft.com/office/drawing/2014/main" id="{64155CD9-63F5-7FBB-5BDC-CC63CDA2A2FE}"/>
               </a:ext>
             </a:extLst>
           </p:cNvPr>
@@ -1526,7 +1526,7 @@
           <p:cNvPr id="3" name="文字版面配置區 2">
             <a:extLst>
               <a:ext uri="{FF2B5EF4-FFF2-40B4-BE49-F238E27FC236}">
-                <a16:creationId xmlns:a16="http://schemas.microsoft.com/office/drawing/2014/main" id="{A3273046-15DD-6E36-9AAC-86E9A34259F6}"/>
+                <a16:creationId xmlns:a16="http://schemas.microsoft.com/office/drawing/2014/main" id="{ED9CB80E-49BE-290C-2C65-785A3EC450BB}"/>
               </a:ext>
             </a:extLst>
           </p:cNvPr>
@@ -1597,7 +1597,7 @@
           <p:cNvPr id="4" name="內容版面配置區 3">
             <a:extLst>
               <a:ext uri="{FF2B5EF4-FFF2-40B4-BE49-F238E27FC236}">
-                <a16:creationId xmlns:a16="http://schemas.microsoft.com/office/drawing/2014/main" id="{AA77A06A-81E0-7F52-5FA0-BAAE04C006A2}"/>
+                <a16:creationId xmlns:a16="http://schemas.microsoft.com/office/drawing/2014/main" id="{659ADC93-7EAD-5F6D-3CEE-C89F341593B1}"/>
               </a:ext>
             </a:extLst>
           </p:cNvPr>
@@ -1659,7 +1659,7 @@
           <p:cNvPr id="5" name="文字版面配置區 4">
             <a:extLst>
               <a:ext uri="{FF2B5EF4-FFF2-40B4-BE49-F238E27FC236}">
-                <a16:creationId xmlns:a16="http://schemas.microsoft.com/office/drawing/2014/main" id="{788E71FD-E00B-BD4C-33E3-CE413FD4F7F1}"/>
+                <a16:creationId xmlns:a16="http://schemas.microsoft.com/office/drawing/2014/main" id="{69DAD588-A101-48A8-ABC7-A008EE567F38}"/>
               </a:ext>
             </a:extLst>
           </p:cNvPr>
@@ -1730,7 +1730,7 @@
           <p:cNvPr id="6" name="內容版面配置區 5">
             <a:extLst>
               <a:ext uri="{FF2B5EF4-FFF2-40B4-BE49-F238E27FC236}">
-                <a16:creationId xmlns:a16="http://schemas.microsoft.com/office/drawing/2014/main" id="{568DE803-AB72-BF0F-8A4F-5133083618F6}"/>
+                <a16:creationId xmlns:a16="http://schemas.microsoft.com/office/drawing/2014/main" id="{1ABF9242-6538-0E09-F325-B560163A5D54}"/>
               </a:ext>
             </a:extLst>
           </p:cNvPr>
@@ -1792,7 +1792,7 @@
           <p:cNvPr id="7" name="日期版面配置區 6">
             <a:extLst>
               <a:ext uri="{FF2B5EF4-FFF2-40B4-BE49-F238E27FC236}">
-                <a16:creationId xmlns:a16="http://schemas.microsoft.com/office/drawing/2014/main" id="{F8FC9C49-FC0E-ED2C-7137-E5B0A3688E4A}"/>
+                <a16:creationId xmlns:a16="http://schemas.microsoft.com/office/drawing/2014/main" id="{90BF8BE2-6E60-CA25-3ADF-41256F8FA9DF}"/>
               </a:ext>
             </a:extLst>
           </p:cNvPr>
@@ -1808,7 +1808,7 @@
           <a:bodyPr/>
           <a:lstStyle/>
           <a:p>
-            <a:fld id="{49A4FC28-A91B-426C-8314-47BE114A8C69}" type="datetimeFigureOut">
+            <a:fld id="{1C769F6A-7DA7-4601-8260-93A464B264CF}" type="datetimeFigureOut">
               <a:rPr lang="zh-TW" altLang="en-US" smtClean="0"/>
               <a:t>2026/5/25</a:t>
             </a:fld>
@@ -1821,7 +1821,7 @@
           <p:cNvPr id="8" name="頁尾版面配置區 7">
             <a:extLst>
               <a:ext uri="{FF2B5EF4-FFF2-40B4-BE49-F238E27FC236}">
-                <a16:creationId xmlns:a16="http://schemas.microsoft.com/office/drawing/2014/main" id="{55E9B56D-C337-670F-3175-E1C0EBB51E74}"/>
+                <a16:creationId xmlns:a16="http://schemas.microsoft.com/office/drawing/2014/main" id="{87E1236A-04E7-E98D-414C-5CBEA8AB1DF2}"/>
               </a:ext>
             </a:extLst>
           </p:cNvPr>
@@ -1846,7 +1846,7 @@
           <p:cNvPr id="9" name="投影片編號版面配置區 8">
             <a:extLst>
               <a:ext uri="{FF2B5EF4-FFF2-40B4-BE49-F238E27FC236}">
-                <a16:creationId xmlns:a16="http://schemas.microsoft.com/office/drawing/2014/main" id="{5150FF4F-15C3-B5D5-0F8F-FABA2BF87339}"/>
+                <a16:creationId xmlns:a16="http://schemas.microsoft.com/office/drawing/2014/main" id="{AE10FA85-6D92-A263-6D67-25C112641E4A}"/>
               </a:ext>
             </a:extLst>
           </p:cNvPr>
@@ -1862,7 +1862,7 @@
           <a:bodyPr/>
           <a:lstStyle/>
           <a:p>
-            <a:fld id="{24E37152-1061-4887-A133-42AB91A9FA6A}" type="slidenum">
+            <a:fld id="{D34EAC9D-8C0A-4F5D-938E-826571E3FC8C}" type="slidenum">
               <a:rPr lang="zh-TW" altLang="en-US" smtClean="0"/>
               <a:t>‹#›</a:t>
             </a:fld>
@@ -1873,7 +1873,7 @@
     </p:spTree>
     <p:extLst>
       <p:ext uri="{BB962C8B-B14F-4D97-AF65-F5344CB8AC3E}">
-        <p14:creationId xmlns:p14="http://schemas.microsoft.com/office/powerpoint/2010/main" val="2456950216"/>
+        <p14:creationId xmlns:p14="http://schemas.microsoft.com/office/powerpoint/2010/main" val="4163664766"/>
       </p:ext>
     </p:extLst>
   </p:cSld>
@@ -1905,7 +1905,7 @@
           <p:cNvPr id="2" name="標題 1">
             <a:extLst>
               <a:ext uri="{FF2B5EF4-FFF2-40B4-BE49-F238E27FC236}">
-                <a16:creationId xmlns:a16="http://schemas.microsoft.com/office/drawing/2014/main" id="{6BD860E2-1BBD-ECDB-D169-5D98FA1DA25D}"/>
+                <a16:creationId xmlns:a16="http://schemas.microsoft.com/office/drawing/2014/main" id="{F87F57BD-56DB-20B1-63D8-B22E28F1C014}"/>
               </a:ext>
             </a:extLst>
           </p:cNvPr>
@@ -1933,7 +1933,7 @@
           <p:cNvPr id="3" name="日期版面配置區 2">
             <a:extLst>
               <a:ext uri="{FF2B5EF4-FFF2-40B4-BE49-F238E27FC236}">
-                <a16:creationId xmlns:a16="http://schemas.microsoft.com/office/drawing/2014/main" id="{F9604929-A558-977A-5B21-7B63934ACD1E}"/>
+                <a16:creationId xmlns:a16="http://schemas.microsoft.com/office/drawing/2014/main" id="{5DB6FC0B-884D-20D0-B543-5554716E2018}"/>
               </a:ext>
             </a:extLst>
           </p:cNvPr>
@@ -1949,7 +1949,7 @@
           <a:bodyPr/>
           <a:lstStyle/>
           <a:p>
-            <a:fld id="{49A4FC28-A91B-426C-8314-47BE114A8C69}" type="datetimeFigureOut">
+            <a:fld id="{1C769F6A-7DA7-4601-8260-93A464B264CF}" type="datetimeFigureOut">
               <a:rPr lang="zh-TW" altLang="en-US" smtClean="0"/>
               <a:t>2026/5/25</a:t>
             </a:fld>
@@ -1962,7 +1962,7 @@
           <p:cNvPr id="4" name="頁尾版面配置區 3">
             <a:extLst>
               <a:ext uri="{FF2B5EF4-FFF2-40B4-BE49-F238E27FC236}">
-                <a16:creationId xmlns:a16="http://schemas.microsoft.com/office/drawing/2014/main" id="{3997CF39-9B32-BB5D-6BA4-0087C3DD789D}"/>
+                <a16:creationId xmlns:a16="http://schemas.microsoft.com/office/drawing/2014/main" id="{E21ECEF7-45DB-BA58-7601-EC907D6CD2FB}"/>
               </a:ext>
             </a:extLst>
           </p:cNvPr>
@@ -1987,7 +1987,7 @@
           <p:cNvPr id="5" name="投影片編號版面配置區 4">
             <a:extLst>
               <a:ext uri="{FF2B5EF4-FFF2-40B4-BE49-F238E27FC236}">
-                <a16:creationId xmlns:a16="http://schemas.microsoft.com/office/drawing/2014/main" id="{440787D4-8072-638E-28FF-FE4579E0BCDE}"/>
+                <a16:creationId xmlns:a16="http://schemas.microsoft.com/office/drawing/2014/main" id="{85F737B5-2280-D325-FE86-87659A837AE4}"/>
               </a:ext>
             </a:extLst>
           </p:cNvPr>
@@ -2003,7 +2003,7 @@
           <a:bodyPr/>
           <a:lstStyle/>
           <a:p>
-            <a:fld id="{24E37152-1061-4887-A133-42AB91A9FA6A}" type="slidenum">
+            <a:fld id="{D34EAC9D-8C0A-4F5D-938E-826571E3FC8C}" type="slidenum">
               <a:rPr lang="zh-TW" altLang="en-US" smtClean="0"/>
               <a:t>‹#›</a:t>
             </a:fld>
@@ -2014,7 +2014,7 @@
     </p:spTree>
     <p:extLst>
       <p:ext uri="{BB962C8B-B14F-4D97-AF65-F5344CB8AC3E}">
-        <p14:creationId xmlns:p14="http://schemas.microsoft.com/office/powerpoint/2010/main" val="2571746978"/>
+        <p14:creationId xmlns:p14="http://schemas.microsoft.com/office/powerpoint/2010/main" val="607802313"/>
       </p:ext>
     </p:extLst>
   </p:cSld>
@@ -2046,7 +2046,7 @@
           <p:cNvPr id="2" name="日期版面配置區 1">
             <a:extLst>
               <a:ext uri="{FF2B5EF4-FFF2-40B4-BE49-F238E27FC236}">
-                <a16:creationId xmlns:a16="http://schemas.microsoft.com/office/drawing/2014/main" id="{6E63513D-C964-373C-390D-A208A9FE5278}"/>
+                <a16:creationId xmlns:a16="http://schemas.microsoft.com/office/drawing/2014/main" id="{F19E1685-AB74-C870-8571-3E8A24D3B812}"/>
               </a:ext>
             </a:extLst>
           </p:cNvPr>
@@ -2062,7 +2062,7 @@
           <a:bodyPr/>
           <a:lstStyle/>
           <a:p>
-            <a:fld id="{49A4FC28-A91B-426C-8314-47BE114A8C69}" type="datetimeFigureOut">
+            <a:fld id="{1C769F6A-7DA7-4601-8260-93A464B264CF}" type="datetimeFigureOut">
               <a:rPr lang="zh-TW" altLang="en-US" smtClean="0"/>
               <a:t>2026/5/25</a:t>
             </a:fld>
@@ -2075,7 +2075,7 @@
           <p:cNvPr id="3" name="頁尾版面配置區 2">
             <a:extLst>
               <a:ext uri="{FF2B5EF4-FFF2-40B4-BE49-F238E27FC236}">
-                <a16:creationId xmlns:a16="http://schemas.microsoft.com/office/drawing/2014/main" id="{ECFE08A0-4AA3-2B39-CD4D-EFD316D64467}"/>
+                <a16:creationId xmlns:a16="http://schemas.microsoft.com/office/drawing/2014/main" id="{110974C6-3EB0-6260-9101-B986AC990CB9}"/>
               </a:ext>
             </a:extLst>
           </p:cNvPr>
@@ -2100,7 +2100,7 @@
           <p:cNvPr id="4" name="投影片編號版面配置區 3">
             <a:extLst>
               <a:ext uri="{FF2B5EF4-FFF2-40B4-BE49-F238E27FC236}">
-                <a16:creationId xmlns:a16="http://schemas.microsoft.com/office/drawing/2014/main" id="{B927F3D1-1F01-FDD4-E380-FAFA8026D9E0}"/>
+                <a16:creationId xmlns:a16="http://schemas.microsoft.com/office/drawing/2014/main" id="{BFB9D277-FF14-B1EF-229D-F9667A3D89E0}"/>
               </a:ext>
             </a:extLst>
           </p:cNvPr>
@@ -2116,7 +2116,7 @@
           <a:bodyPr/>
           <a:lstStyle/>
           <a:p>
-            <a:fld id="{24E37152-1061-4887-A133-42AB91A9FA6A}" type="slidenum">
+            <a:fld id="{D34EAC9D-8C0A-4F5D-938E-826571E3FC8C}" type="slidenum">
               <a:rPr lang="zh-TW" altLang="en-US" smtClean="0"/>
               <a:t>‹#›</a:t>
             </a:fld>
@@ -2127,7 +2127,7 @@
     </p:spTree>
     <p:extLst>
       <p:ext uri="{BB962C8B-B14F-4D97-AF65-F5344CB8AC3E}">
-        <p14:creationId xmlns:p14="http://schemas.microsoft.com/office/powerpoint/2010/main" val="550487021"/>
+        <p14:creationId xmlns:p14="http://schemas.microsoft.com/office/powerpoint/2010/main" val="2112962706"/>
       </p:ext>
     </p:extLst>
   </p:cSld>
@@ -2159,7 +2159,7 @@
           <p:cNvPr id="2" name="標題 1">
             <a:extLst>
               <a:ext uri="{FF2B5EF4-FFF2-40B4-BE49-F238E27FC236}">
-                <a16:creationId xmlns:a16="http://schemas.microsoft.com/office/drawing/2014/main" id="{D3158D89-E08F-6B06-E191-CEAB3D4FCFFB}"/>
+                <a16:creationId xmlns:a16="http://schemas.microsoft.com/office/drawing/2014/main" id="{D0F955F5-B766-803C-17F5-241EAB116AB1}"/>
               </a:ext>
             </a:extLst>
           </p:cNvPr>
@@ -2196,7 +2196,7 @@
           <p:cNvPr id="3" name="內容版面配置區 2">
             <a:extLst>
               <a:ext uri="{FF2B5EF4-FFF2-40B4-BE49-F238E27FC236}">
-                <a16:creationId xmlns:a16="http://schemas.microsoft.com/office/drawing/2014/main" id="{9A348D51-4451-1204-3AD5-CCC108A78E43}"/>
+                <a16:creationId xmlns:a16="http://schemas.microsoft.com/office/drawing/2014/main" id="{9FA1BB47-382A-2AE4-F2E1-5CA8F0676D08}"/>
               </a:ext>
             </a:extLst>
           </p:cNvPr>
@@ -2286,7 +2286,7 @@
           <p:cNvPr id="4" name="文字版面配置區 3">
             <a:extLst>
               <a:ext uri="{FF2B5EF4-FFF2-40B4-BE49-F238E27FC236}">
-                <a16:creationId xmlns:a16="http://schemas.microsoft.com/office/drawing/2014/main" id="{290983C4-3456-8963-954E-0D6ABF02B86F}"/>
+                <a16:creationId xmlns:a16="http://schemas.microsoft.com/office/drawing/2014/main" id="{A6A1E336-3775-7FBA-B8AD-1F7C9DA641A9}"/>
               </a:ext>
             </a:extLst>
           </p:cNvPr>
@@ -2357,7 +2357,7 @@
           <p:cNvPr id="5" name="日期版面配置區 4">
             <a:extLst>
               <a:ext uri="{FF2B5EF4-FFF2-40B4-BE49-F238E27FC236}">
-                <a16:creationId xmlns:a16="http://schemas.microsoft.com/office/drawing/2014/main" id="{B7E3F663-8242-4D2D-59DD-4258439AEB33}"/>
+                <a16:creationId xmlns:a16="http://schemas.microsoft.com/office/drawing/2014/main" id="{53F4BB3F-77A5-328C-EBFD-FA0AB1E13BB2}"/>
               </a:ext>
             </a:extLst>
           </p:cNvPr>
@@ -2373,7 +2373,7 @@
           <a:bodyPr/>
           <a:lstStyle/>
           <a:p>
-            <a:fld id="{49A4FC28-A91B-426C-8314-47BE114A8C69}" type="datetimeFigureOut">
+            <a:fld id="{1C769F6A-7DA7-4601-8260-93A464B264CF}" type="datetimeFigureOut">
               <a:rPr lang="zh-TW" altLang="en-US" smtClean="0"/>
               <a:t>2026/5/25</a:t>
             </a:fld>
@@ -2386,7 +2386,7 @@
           <p:cNvPr id="6" name="頁尾版面配置區 5">
             <a:extLst>
               <a:ext uri="{FF2B5EF4-FFF2-40B4-BE49-F238E27FC236}">
-                <a16:creationId xmlns:a16="http://schemas.microsoft.com/office/drawing/2014/main" id="{2FBB0AB1-D21B-9FBF-A2BD-29ED1DF9ED25}"/>
+                <a16:creationId xmlns:a16="http://schemas.microsoft.com/office/drawing/2014/main" id="{54B07D35-6619-862B-835D-7EBB8C885772}"/>
               </a:ext>
             </a:extLst>
           </p:cNvPr>
@@ -2411,7 +2411,7 @@
           <p:cNvPr id="7" name="投影片編號版面配置區 6">
             <a:extLst>
               <a:ext uri="{FF2B5EF4-FFF2-40B4-BE49-F238E27FC236}">
-                <a16:creationId xmlns:a16="http://schemas.microsoft.com/office/drawing/2014/main" id="{A08674E0-0F9E-6BBB-7886-D66B9482595A}"/>
+                <a16:creationId xmlns:a16="http://schemas.microsoft.com/office/drawing/2014/main" id="{E9569DD0-1BA8-AD9E-E698-38BBADAB57D4}"/>
               </a:ext>
             </a:extLst>
           </p:cNvPr>
@@ -2427,7 +2427,7 @@
           <a:bodyPr/>
           <a:lstStyle/>
           <a:p>
-            <a:fld id="{24E37152-1061-4887-A133-42AB91A9FA6A}" type="slidenum">
+            <a:fld id="{D34EAC9D-8C0A-4F5D-938E-826571E3FC8C}" type="slidenum">
               <a:rPr lang="zh-TW" altLang="en-US" smtClean="0"/>
               <a:t>‹#›</a:t>
             </a:fld>
@@ -2438,7 +2438,7 @@
     </p:spTree>
     <p:extLst>
       <p:ext uri="{BB962C8B-B14F-4D97-AF65-F5344CB8AC3E}">
-        <p14:creationId xmlns:p14="http://schemas.microsoft.com/office/powerpoint/2010/main" val="2514518163"/>
+        <p14:creationId xmlns:p14="http://schemas.microsoft.com/office/powerpoint/2010/main" val="288848408"/>
       </p:ext>
     </p:extLst>
   </p:cSld>
@@ -2470,7 +2470,7 @@
           <p:cNvPr id="2" name="標題 1">
             <a:extLst>
               <a:ext uri="{FF2B5EF4-FFF2-40B4-BE49-F238E27FC236}">
-                <a16:creationId xmlns:a16="http://schemas.microsoft.com/office/drawing/2014/main" id="{C767C660-FB7B-C40E-10F5-3D5416DB6310}"/>
+                <a16:creationId xmlns:a16="http://schemas.microsoft.com/office/drawing/2014/main" id="{BBECAF65-CF30-7877-B0B1-C9A5BA36D286}"/>
               </a:ext>
             </a:extLst>
           </p:cNvPr>
@@ -2507,7 +2507,7 @@
           <p:cNvPr id="3" name="圖片版面配置區 2">
             <a:extLst>
               <a:ext uri="{FF2B5EF4-FFF2-40B4-BE49-F238E27FC236}">
-                <a16:creationId xmlns:a16="http://schemas.microsoft.com/office/drawing/2014/main" id="{2F67681E-4632-7CA7-7608-364A5A4BE78C}"/>
+                <a16:creationId xmlns:a16="http://schemas.microsoft.com/office/drawing/2014/main" id="{B140D6B7-14F7-AF20-7AF0-103AB61EC7CD}"/>
               </a:ext>
             </a:extLst>
           </p:cNvPr>
@@ -2574,7 +2574,7 @@
           <p:cNvPr id="4" name="文字版面配置區 3">
             <a:extLst>
               <a:ext uri="{FF2B5EF4-FFF2-40B4-BE49-F238E27FC236}">
-                <a16:creationId xmlns:a16="http://schemas.microsoft.com/office/drawing/2014/main" id="{C8C3EE6F-C988-79AD-CE92-DCBDFF67A0FB}"/>
+                <a16:creationId xmlns:a16="http://schemas.microsoft.com/office/drawing/2014/main" id="{6DA85B12-14E9-FF1D-4FC1-263AB5FFD92F}"/>
               </a:ext>
             </a:extLst>
           </p:cNvPr>
@@ -2645,7 +2645,7 @@
           <p:cNvPr id="5" name="日期版面配置區 4">
             <a:extLst>
               <a:ext uri="{FF2B5EF4-FFF2-40B4-BE49-F238E27FC236}">
-                <a16:creationId xmlns:a16="http://schemas.microsoft.com/office/drawing/2014/main" id="{F8760E80-77BD-30EF-D5D7-A7ACC6AFE270}"/>
+                <a16:creationId xmlns:a16="http://schemas.microsoft.com/office/drawing/2014/main" id="{283A5729-40EB-AC98-FCE5-7BAED771CD21}"/>
               </a:ext>
             </a:extLst>
           </p:cNvPr>
@@ -2661,7 +2661,7 @@
           <a:bodyPr/>
           <a:lstStyle/>
           <a:p>
-            <a:fld id="{49A4FC28-A91B-426C-8314-47BE114A8C69}" type="datetimeFigureOut">
+            <a:fld id="{1C769F6A-7DA7-4601-8260-93A464B264CF}" type="datetimeFigureOut">
               <a:rPr lang="zh-TW" altLang="en-US" smtClean="0"/>
               <a:t>2026/5/25</a:t>
             </a:fld>
@@ -2674,7 +2674,7 @@
           <p:cNvPr id="6" name="頁尾版面配置區 5">
             <a:extLst>
               <a:ext uri="{FF2B5EF4-FFF2-40B4-BE49-F238E27FC236}">
-                <a16:creationId xmlns:a16="http://schemas.microsoft.com/office/drawing/2014/main" id="{962DFAA9-6596-F575-6E15-7E82A3C984DD}"/>
+                <a16:creationId xmlns:a16="http://schemas.microsoft.com/office/drawing/2014/main" id="{A7FBC40E-8B19-4CAF-7BE8-AB34FEBA502B}"/>
               </a:ext>
             </a:extLst>
           </p:cNvPr>
@@ -2699,7 +2699,7 @@
           <p:cNvPr id="7" name="投影片編號版面配置區 6">
             <a:extLst>
               <a:ext uri="{FF2B5EF4-FFF2-40B4-BE49-F238E27FC236}">
-                <a16:creationId xmlns:a16="http://schemas.microsoft.com/office/drawing/2014/main" id="{FBD5B6A0-26FF-E7FA-F0DB-67A12177C635}"/>
+                <a16:creationId xmlns:a16="http://schemas.microsoft.com/office/drawing/2014/main" id="{DF54C0C7-ED06-553F-C805-ED4750631058}"/>
               </a:ext>
             </a:extLst>
           </p:cNvPr>
@@ -2715,7 +2715,7 @@
           <a:bodyPr/>
           <a:lstStyle/>
           <a:p>
-            <a:fld id="{24E37152-1061-4887-A133-42AB91A9FA6A}" type="slidenum">
+            <a:fld id="{D34EAC9D-8C0A-4F5D-938E-826571E3FC8C}" type="slidenum">
               <a:rPr lang="zh-TW" altLang="en-US" smtClean="0"/>
               <a:t>‹#›</a:t>
             </a:fld>
@@ -2726,7 +2726,7 @@
     </p:spTree>
     <p:extLst>
       <p:ext uri="{BB962C8B-B14F-4D97-AF65-F5344CB8AC3E}">
-        <p14:creationId xmlns:p14="http://schemas.microsoft.com/office/powerpoint/2010/main" val="4045544069"/>
+        <p14:creationId xmlns:p14="http://schemas.microsoft.com/office/powerpoint/2010/main" val="2451912389"/>
       </p:ext>
     </p:extLst>
   </p:cSld>
@@ -2763,7 +2763,7 @@
           <p:cNvPr id="2" name="標題版面配置區 1">
             <a:extLst>
               <a:ext uri="{FF2B5EF4-FFF2-40B4-BE49-F238E27FC236}">
-                <a16:creationId xmlns:a16="http://schemas.microsoft.com/office/drawing/2014/main" id="{50BA9B79-77A5-D635-E002-D184921D66EE}"/>
+                <a16:creationId xmlns:a16="http://schemas.microsoft.com/office/drawing/2014/main" id="{A09A7703-64E4-67E5-5335-6D4E1A0658FA}"/>
               </a:ext>
             </a:extLst>
           </p:cNvPr>
@@ -2801,7 +2801,7 @@
           <p:cNvPr id="3" name="文字版面配置區 2">
             <a:extLst>
               <a:ext uri="{FF2B5EF4-FFF2-40B4-BE49-F238E27FC236}">
-                <a16:creationId xmlns:a16="http://schemas.microsoft.com/office/drawing/2014/main" id="{DE64C679-72FA-AA71-7BA3-1477FBECFDD2}"/>
+                <a16:creationId xmlns:a16="http://schemas.microsoft.com/office/drawing/2014/main" id="{42553845-8DC2-0B72-F818-95E24DA2A70E}"/>
               </a:ext>
             </a:extLst>
           </p:cNvPr>
@@ -2868,7 +2868,7 @@
           <p:cNvPr id="4" name="日期版面配置區 3">
             <a:extLst>
               <a:ext uri="{FF2B5EF4-FFF2-40B4-BE49-F238E27FC236}">
-                <a16:creationId xmlns:a16="http://schemas.microsoft.com/office/drawing/2014/main" id="{0ED8B8C7-FB1F-D4FF-46B8-D9CEAFDF6E0E}"/>
+                <a16:creationId xmlns:a16="http://schemas.microsoft.com/office/drawing/2014/main" id="{85DC4AB8-4CDF-7082-E340-B105F5CDE460}"/>
               </a:ext>
             </a:extLst>
           </p:cNvPr>
@@ -2902,7 +2902,7 @@
             </a:lvl1pPr>
           </a:lstStyle>
           <a:p>
-            <a:fld id="{49A4FC28-A91B-426C-8314-47BE114A8C69}" type="datetimeFigureOut">
+            <a:fld id="{1C769F6A-7DA7-4601-8260-93A464B264CF}" type="datetimeFigureOut">
               <a:rPr lang="zh-TW" altLang="en-US" smtClean="0"/>
               <a:t>2026/5/25</a:t>
             </a:fld>
@@ -2915,7 +2915,7 @@
           <p:cNvPr id="5" name="頁尾版面配置區 4">
             <a:extLst>
               <a:ext uri="{FF2B5EF4-FFF2-40B4-BE49-F238E27FC236}">
-                <a16:creationId xmlns:a16="http://schemas.microsoft.com/office/drawing/2014/main" id="{A08C70DF-4924-170F-B9FC-5F3FE920E8AF}"/>
+                <a16:creationId xmlns:a16="http://schemas.microsoft.com/office/drawing/2014/main" id="{7CA365E7-AD84-8231-649E-BD22BB95EBF6}"/>
               </a:ext>
             </a:extLst>
           </p:cNvPr>
@@ -2958,7 +2958,7 @@
           <p:cNvPr id="6" name="投影片編號版面配置區 5">
             <a:extLst>
               <a:ext uri="{FF2B5EF4-FFF2-40B4-BE49-F238E27FC236}">
-                <a16:creationId xmlns:a16="http://schemas.microsoft.com/office/drawing/2014/main" id="{C20F6145-F799-B0B2-F623-3E67080BDE2C}"/>
+                <a16:creationId xmlns:a16="http://schemas.microsoft.com/office/drawing/2014/main" id="{0D39038F-A482-C048-7DC8-619562AA8BD4}"/>
               </a:ext>
             </a:extLst>
           </p:cNvPr>
@@ -2992,7 +2992,7 @@
             </a:lvl1pPr>
           </a:lstStyle>
           <a:p>
-            <a:fld id="{24E37152-1061-4887-A133-42AB91A9FA6A}" type="slidenum">
+            <a:fld id="{D34EAC9D-8C0A-4F5D-938E-826571E3FC8C}" type="slidenum">
               <a:rPr lang="zh-TW" altLang="en-US" smtClean="0"/>
               <a:t>‹#›</a:t>
             </a:fld>
@@ -3003,7 +3003,7 @@
     </p:spTree>
     <p:extLst>
       <p:ext uri="{BB962C8B-B14F-4D97-AF65-F5344CB8AC3E}">
-        <p14:creationId xmlns:p14="http://schemas.microsoft.com/office/powerpoint/2010/main" val="3658249255"/>
+        <p14:creationId xmlns:p14="http://schemas.microsoft.com/office/powerpoint/2010/main" val="2309173399"/>
       </p:ext>
     </p:extLst>
   </p:cSld>
@@ -3326,7 +3326,7 @@
           <p:cNvPr id="3" name="圖片 2">
             <a:extLst>
               <a:ext uri="{FF2B5EF4-FFF2-40B4-BE49-F238E27FC236}">
-                <a16:creationId xmlns:a16="http://schemas.microsoft.com/office/drawing/2014/main" id="{36AF1912-51A6-D43C-A788-85E0F5AED5EE}"/>
+                <a16:creationId xmlns:a16="http://schemas.microsoft.com/office/drawing/2014/main" id="{2475C6F2-8334-B7B0-D2F1-61919CABB145}"/>
               </a:ext>
             </a:extLst>
           </p:cNvPr>
@@ -3362,7 +3362,7 @@
           <p:cNvPr id="4" name="矩形: 圓角 3">
             <a:extLst>
               <a:ext uri="{FF2B5EF4-FFF2-40B4-BE49-F238E27FC236}">
-                <a16:creationId xmlns:a16="http://schemas.microsoft.com/office/drawing/2014/main" id="{21BC3223-6E17-208E-6DE7-4C2DA5E1B5B1}"/>
+                <a16:creationId xmlns:a16="http://schemas.microsoft.com/office/drawing/2014/main" id="{738DDFCB-62AB-300C-8223-E8B3635CD322}"/>
               </a:ext>
             </a:extLst>
           </p:cNvPr>
@@ -3371,21 +3371,21 @@
         </p:nvSpPr>
         <p:spPr>
           <a:xfrm>
-            <a:off x="977900" y="2133600"/>
-            <a:ext cx="3886200" cy="2463800"/>
+            <a:off x="939800" y="1917700"/>
+            <a:ext cx="3975100" cy="3403600"/>
           </a:xfrm>
           <a:prstGeom prst="roundRect">
             <a:avLst/>
           </a:prstGeom>
           <a:solidFill>
             <a:srgbClr val="FFFFFF">
-              <a:alpha val="82000"/>
+              <a:alpha val="88000"/>
             </a:srgbClr>
           </a:solidFill>
           <a:ln w="13970" cap="flat" cmpd="sng" algn="ctr">
             <a:solidFill>
               <a:srgbClr val="84B5EB">
-                <a:alpha val="92000"/>
+                <a:alpha val="96000"/>
               </a:srgbClr>
             </a:solidFill>
             <a:prstDash val="solid"/>
@@ -3424,7 +3424,7 @@
           <p:cNvPr id="5" name="文字方塊 4">
             <a:extLst>
               <a:ext uri="{FF2B5EF4-FFF2-40B4-BE49-F238E27FC236}">
-                <a16:creationId xmlns:a16="http://schemas.microsoft.com/office/drawing/2014/main" id="{866C5E7C-6B95-44E5-0688-43B3777300BB}"/>
+                <a16:creationId xmlns:a16="http://schemas.microsoft.com/office/drawing/2014/main" id="{61DD6EC1-E214-1D2A-D585-98756A9EB963}"/>
               </a:ext>
             </a:extLst>
           </p:cNvPr>
@@ -3433,8 +3433,8 @@
         </p:nvSpPr>
         <p:spPr>
           <a:xfrm>
-            <a:off x="1308100" y="2374900"/>
-            <a:ext cx="3225800" cy="276999"/>
+            <a:off x="1244600" y="2159000"/>
+            <a:ext cx="3378200" cy="276999"/>
           </a:xfrm>
           <a:prstGeom prst="rect">
             <a:avLst/>
@@ -3447,72 +3447,48 @@
           </a:bodyPr>
           <a:lstStyle/>
           <a:p>
-            <a:r>
-              <a:rPr lang="zh-TW" altLang="en-US" sz="1320">
+            <a:pPr>
+              <a:lnSpc>
+                <a:spcPct val="92000"/>
+              </a:lnSpc>
+            </a:pPr>
+            <a:r>
+              <a:rPr lang="en-US" altLang="zh-TW" sz="935">
                 <a:solidFill>
                   <a:srgbClr val="103B6E"/>
                 </a:solidFill>
                 <a:latin typeface="Microsoft JhengHei" panose="020B0604030504040204" pitchFamily="34" charset="-120"/>
               </a:rPr>
-              <a:t>不是再做一個租屋刊登平台，
-而是建立租客看得懂的資訊透明基礎。
-</a:t>
-            </a:r>
-            <a:r>
-              <a:rPr lang="en-US" altLang="zh-TW" sz="1320">
+              <a:t>Rent Unfiltered </a:t>
+            </a:r>
+            <a:r>
+              <a:rPr lang="zh-TW" altLang="en-US" sz="935">
                 <a:solidFill>
                   <a:srgbClr val="103B6E"/>
                 </a:solidFill>
                 <a:latin typeface="Microsoft JhengHei" panose="020B0604030504040204" pitchFamily="34" charset="-120"/>
               </a:rPr>
-              <a:t>• </a:t>
-            </a:r>
-            <a:r>
-              <a:rPr lang="zh-TW" altLang="en-US" sz="1320">
+              <a:t>並不是另一個租屋刊登平台，也不是主觀評論平台，而是嘗試建立一套面向租客的租屋資訊透明化基礎設施。
+目前租屋資訊常受到廣告排序、平台曝光、行銷包裝與資訊不對稱影響。對學生與第一次租屋者而言，真正重要的風險，例如押金規範、水電費計算、修繕責任、報稅權益、遷戶籍限制與居住安全，往往被隱藏在零散資訊與複雜條款之中。
+因此，本專案希望透過一套可解釋、可量化、可比較的租屋風險指標，讓租屋物件不再只依賴流量與包裝獲得曝光，而能透過一致標準被檢視。</a:t>
+            </a:r>
+            <a:r>
+              <a:rPr lang="en-US" altLang="zh-TW" sz="935">
                 <a:solidFill>
                   <a:srgbClr val="103B6E"/>
                 </a:solidFill>
                 <a:latin typeface="Microsoft JhengHei" panose="020B0604030504040204" pitchFamily="34" charset="-120"/>
               </a:rPr>
-              <a:t>把零散條款整理成清楚格式
-</a:t>
-            </a:r>
-            <a:r>
-              <a:rPr lang="en-US" altLang="zh-TW" sz="1320">
+              <a:t>Unfiltered </a:t>
+            </a:r>
+            <a:r>
+              <a:rPr lang="zh-TW" altLang="en-US" sz="935">
                 <a:solidFill>
                   <a:srgbClr val="103B6E"/>
                 </a:solidFill>
                 <a:latin typeface="Microsoft JhengHei" panose="020B0604030504040204" pitchFamily="34" charset="-120"/>
               </a:rPr>
-              <a:t>• </a:t>
-            </a:r>
-            <a:r>
-              <a:rPr lang="zh-TW" altLang="en-US" sz="1320">
-                <a:solidFill>
-                  <a:srgbClr val="103B6E"/>
-                </a:solidFill>
-                <a:latin typeface="Microsoft JhengHei" panose="020B0604030504040204" pitchFamily="34" charset="-120"/>
-              </a:rPr>
-              <a:t>讓契約、費用、安全、權益可比較
-</a:t>
-            </a:r>
-            <a:r>
-              <a:rPr lang="en-US" altLang="zh-TW" sz="1320">
-                <a:solidFill>
-                  <a:srgbClr val="103B6E"/>
-                </a:solidFill>
-                <a:latin typeface="Microsoft JhengHei" panose="020B0604030504040204" pitchFamily="34" charset="-120"/>
-              </a:rPr>
-              <a:t>• </a:t>
-            </a:r>
-            <a:r>
-              <a:rPr lang="zh-TW" altLang="en-US" sz="1320">
-                <a:solidFill>
-                  <a:srgbClr val="103B6E"/>
-                </a:solidFill>
-                <a:latin typeface="Microsoft JhengHei" panose="020B0604030504040204" pitchFamily="34" charset="-120"/>
-              </a:rPr>
-              <a:t>讓透明的出租方也能被看見</a:t>
+              <a:t>並不是毫無過濾，而是不被廣告、流量與市場權力過濾。</a:t>
             </a:r>
           </a:p>
         </p:txBody>
@@ -3522,7 +3498,7 @@
           <p:cNvPr id="6" name="矩形: 圓角 5">
             <a:extLst>
               <a:ext uri="{FF2B5EF4-FFF2-40B4-BE49-F238E27FC236}">
-                <a16:creationId xmlns:a16="http://schemas.microsoft.com/office/drawing/2014/main" id="{C1D58A16-8F1A-2B3F-6E85-D65DBD9CFE03}"/>
+                <a16:creationId xmlns:a16="http://schemas.microsoft.com/office/drawing/2014/main" id="{8A3A74A0-878C-CFD3-CCE0-4BB2724744A4}"/>
               </a:ext>
             </a:extLst>
           </p:cNvPr>
@@ -3531,21 +3507,21 @@
         </p:nvSpPr>
         <p:spPr>
           <a:xfrm>
-            <a:off x="7467600" y="2133600"/>
-            <a:ext cx="3886200" cy="2463800"/>
+            <a:off x="7429500" y="1917700"/>
+            <a:ext cx="3975100" cy="3403600"/>
           </a:xfrm>
           <a:prstGeom prst="roundRect">
             <a:avLst/>
           </a:prstGeom>
           <a:solidFill>
             <a:srgbClr val="FFFFFF">
-              <a:alpha val="82000"/>
+              <a:alpha val="88000"/>
             </a:srgbClr>
           </a:solidFill>
           <a:ln w="13970" cap="flat" cmpd="sng" algn="ctr">
             <a:solidFill>
               <a:srgbClr val="84B5EB">
-                <a:alpha val="92000"/>
+                <a:alpha val="96000"/>
               </a:srgbClr>
             </a:solidFill>
             <a:prstDash val="solid"/>
@@ -3584,7 +3560,7 @@
           <p:cNvPr id="7" name="文字方塊 6">
             <a:extLst>
               <a:ext uri="{FF2B5EF4-FFF2-40B4-BE49-F238E27FC236}">
-                <a16:creationId xmlns:a16="http://schemas.microsoft.com/office/drawing/2014/main" id="{CFC31ED3-4FEA-CCB2-71F8-AE03EAC659EA}"/>
+                <a16:creationId xmlns:a16="http://schemas.microsoft.com/office/drawing/2014/main" id="{C22F4E0B-C869-15C2-02A7-6C16DE66607F}"/>
               </a:ext>
             </a:extLst>
           </p:cNvPr>
@@ -3593,8 +3569,8 @@
         </p:nvSpPr>
         <p:spPr>
           <a:xfrm>
-            <a:off x="7797800" y="2374900"/>
-            <a:ext cx="3225800" cy="276999"/>
+            <a:off x="7734300" y="2159000"/>
+            <a:ext cx="3378200" cy="276999"/>
           </a:xfrm>
           <a:prstGeom prst="rect">
             <a:avLst/>
@@ -3607,72 +3583,31 @@
           </a:bodyPr>
           <a:lstStyle/>
           <a:p>
-            <a:r>
-              <a:rPr lang="zh-TW" altLang="en-US" sz="1320">
+            <a:pPr>
+              <a:lnSpc>
+                <a:spcPct val="90000"/>
+              </a:lnSpc>
+            </a:pPr>
+            <a:r>
+              <a:rPr lang="en-US" altLang="zh-TW" sz="920">
                 <a:solidFill>
                   <a:srgbClr val="103B6E"/>
                 </a:solidFill>
                 <a:latin typeface="Microsoft JhengHei" panose="020B0604030504040204" pitchFamily="34" charset="-120"/>
               </a:rPr>
-              <a:t>租屋風險不是少數人的問題，
-而是學生、新鮮人與短期租客常見的共同處境。
-</a:t>
-            </a:r>
-            <a:r>
-              <a:rPr lang="en-US" altLang="zh-TW" sz="1320">
+              <a:t>Rent Unfiltered </a:t>
+            </a:r>
+            <a:r>
+              <a:rPr lang="zh-TW" altLang="en-US" sz="920">
                 <a:solidFill>
                   <a:srgbClr val="103B6E"/>
                 </a:solidFill>
                 <a:latin typeface="Microsoft JhengHei" panose="020B0604030504040204" pitchFamily="34" charset="-120"/>
               </a:rPr>
-              <a:t>• </a:t>
-            </a:r>
-            <a:r>
-              <a:rPr lang="zh-TW" altLang="en-US" sz="1320">
-                <a:solidFill>
-                  <a:srgbClr val="103B6E"/>
-                </a:solidFill>
-                <a:latin typeface="Microsoft JhengHei" panose="020B0604030504040204" pitchFamily="34" charset="-120"/>
-              </a:rPr>
-              <a:t>查核時間少、經驗不足
-</a:t>
-            </a:r>
-            <a:r>
-              <a:rPr lang="en-US" altLang="zh-TW" sz="1320">
-                <a:solidFill>
-                  <a:srgbClr val="103B6E"/>
-                </a:solidFill>
-                <a:latin typeface="Microsoft JhengHei" panose="020B0604030504040204" pitchFamily="34" charset="-120"/>
-              </a:rPr>
-              <a:t>• </a:t>
-            </a:r>
-            <a:r>
-              <a:rPr lang="zh-TW" altLang="en-US" sz="1320">
-                <a:solidFill>
-                  <a:srgbClr val="103B6E"/>
-                </a:solidFill>
-                <a:latin typeface="Microsoft JhengHei" panose="020B0604030504040204" pitchFamily="34" charset="-120"/>
-              </a:rPr>
-              <a:t>資訊取得成本高
-</a:t>
-            </a:r>
-            <a:r>
-              <a:rPr lang="en-US" altLang="zh-TW" sz="1320">
-                <a:solidFill>
-                  <a:srgbClr val="103B6E"/>
-                </a:solidFill>
-                <a:latin typeface="Microsoft JhengHei" panose="020B0604030504040204" pitchFamily="34" charset="-120"/>
-              </a:rPr>
-              <a:t>• </a:t>
-            </a:r>
-            <a:r>
-              <a:rPr lang="zh-TW" altLang="en-US" sz="1320">
-                <a:solidFill>
-                  <a:srgbClr val="103B6E"/>
-                </a:solidFill>
-                <a:latin typeface="Microsoft JhengHei" panose="020B0604030504040204" pitchFamily="34" charset="-120"/>
-              </a:rPr>
-              <a:t>簽約前最需要看見隱藏風險</a:t>
+              <a:t>透明租屋的創作動機，並不是來自個人立即性的租屋需求，而是來自對居住市場與租賃關係的觀察。
+從經濟學角度來看，居住可以被視為一種持續消費的住宅服務。整個社會其實都處於廣義的居住服務關係之中。
+然而，自住者與租屋者在風險控管與生活主權上存在明顯差異。學生、新鮮人與短期租屋者，往往受限於預算、時間與經驗，難以投入同等查核成本。
+因此，租屋者特別是學生族群，常在資訊成本較高、辨別能力較低、承擔能力較弱的情況下，面對契約、費用、居住安全與租客權益等風險。</a:t>
             </a:r>
           </a:p>
         </p:txBody>
@@ -3682,7 +3617,7 @@
           <p:cNvPr id="8" name="矩形: 圓角 7">
             <a:extLst>
               <a:ext uri="{FF2B5EF4-FFF2-40B4-BE49-F238E27FC236}">
-                <a16:creationId xmlns:a16="http://schemas.microsoft.com/office/drawing/2014/main" id="{8A81864E-D5CC-F5F9-7686-4A26CDBDBBCC}"/>
+                <a16:creationId xmlns:a16="http://schemas.microsoft.com/office/drawing/2014/main" id="{2933E31A-5FAE-FA32-2E6F-A02E2E217B83}"/>
               </a:ext>
             </a:extLst>
           </p:cNvPr>
@@ -3691,21 +3626,21 @@
         </p:nvSpPr>
         <p:spPr>
           <a:xfrm>
-            <a:off x="4978400" y="2387600"/>
-            <a:ext cx="2260600" cy="1193800"/>
+            <a:off x="4978400" y="2336800"/>
+            <a:ext cx="2260600" cy="1282700"/>
           </a:xfrm>
           <a:prstGeom prst="roundRect">
             <a:avLst/>
           </a:prstGeom>
           <a:solidFill>
             <a:srgbClr val="FFFFFF">
-              <a:alpha val="92000"/>
+              <a:alpha val="94000"/>
             </a:srgbClr>
           </a:solidFill>
           <a:ln w="13970" cap="flat" cmpd="sng" algn="ctr">
             <a:solidFill>
               <a:srgbClr val="84B5EB">
-                <a:alpha val="92000"/>
+                <a:alpha val="96000"/>
               </a:srgbClr>
             </a:solidFill>
             <a:prstDash val="solid"/>
@@ -3744,7 +3679,7 @@
           <p:cNvPr id="9" name="文字方塊 8">
             <a:extLst>
               <a:ext uri="{FF2B5EF4-FFF2-40B4-BE49-F238E27FC236}">
-                <a16:creationId xmlns:a16="http://schemas.microsoft.com/office/drawing/2014/main" id="{0D3FC790-CFAD-B36B-C313-FF0A383D1E27}"/>
+                <a16:creationId xmlns:a16="http://schemas.microsoft.com/office/drawing/2014/main" id="{7DBCFD94-E679-1964-B2A7-D83F9B068CA9}"/>
               </a:ext>
             </a:extLst>
           </p:cNvPr>
@@ -3753,8 +3688,8 @@
         </p:nvSpPr>
         <p:spPr>
           <a:xfrm>
-            <a:off x="5207000" y="2540000"/>
-            <a:ext cx="1803400" cy="276999"/>
+            <a:off x="5207000" y="2514600"/>
+            <a:ext cx="1828800" cy="276999"/>
           </a:xfrm>
           <a:prstGeom prst="rect">
             <a:avLst/>
@@ -3767,8 +3702,13 @@
           </a:bodyPr>
           <a:lstStyle/>
           <a:p>
-            <a:r>
-              <a:rPr lang="en-US" altLang="zh-TW" sz="1060">
+            <a:pPr>
+              <a:lnSpc>
+                <a:spcPct val="90000"/>
+              </a:lnSpc>
+            </a:pPr>
+            <a:r>
+              <a:rPr lang="en-US" altLang="zh-TW" sz="1020">
                 <a:solidFill>
                   <a:srgbClr val="0E437D"/>
                 </a:solidFill>
@@ -3777,7 +3717,7 @@
               <a:t>AI </a:t>
             </a:r>
             <a:r>
-              <a:rPr lang="zh-TW" altLang="en-US" sz="1060">
+              <a:rPr lang="zh-TW" altLang="en-US" sz="1020">
                 <a:solidFill>
                   <a:srgbClr val="0E437D"/>
                 </a:solidFill>
@@ -3787,7 +3727,7 @@
 </a:t>
             </a:r>
             <a:r>
-              <a:rPr lang="en-US" altLang="zh-TW" sz="1060">
+              <a:rPr lang="en-US" altLang="zh-TW" sz="1020">
                 <a:solidFill>
                   <a:srgbClr val="0E437D"/>
                 </a:solidFill>
@@ -3796,17 +3736,17 @@
               <a:t>• </a:t>
             </a:r>
             <a:r>
-              <a:rPr lang="zh-TW" altLang="en-US" sz="1060">
+              <a:rPr lang="zh-TW" altLang="en-US" sz="1020">
                 <a:solidFill>
                   <a:srgbClr val="0E437D"/>
                 </a:solidFill>
                 <a:latin typeface="Microsoft JhengHei" panose="020B0604030504040204" pitchFamily="34" charset="-120"/>
               </a:rPr>
-              <a:t>整理資訊
+              <a:t>整理資訊與條款
 </a:t>
             </a:r>
             <a:r>
-              <a:rPr lang="en-US" altLang="zh-TW" sz="1060">
+              <a:rPr lang="en-US" altLang="zh-TW" sz="1020">
                 <a:solidFill>
                   <a:srgbClr val="0E437D"/>
                 </a:solidFill>
@@ -3815,17 +3755,17 @@
               <a:t>• </a:t>
             </a:r>
             <a:r>
-              <a:rPr lang="zh-TW" altLang="en-US" sz="1060">
+              <a:rPr lang="zh-TW" altLang="en-US" sz="1020">
                 <a:solidFill>
                   <a:srgbClr val="0E437D"/>
                 </a:solidFill>
                 <a:latin typeface="Microsoft JhengHei" panose="020B0604030504040204" pitchFamily="34" charset="-120"/>
               </a:rPr>
-              <a:t>揭露風險
+              <a:t>揭露契約、費用、安全風險
 </a:t>
             </a:r>
             <a:r>
-              <a:rPr lang="en-US" altLang="zh-TW" sz="1060">
+              <a:rPr lang="en-US" altLang="zh-TW" sz="1020">
                 <a:solidFill>
                   <a:srgbClr val="0E437D"/>
                 </a:solidFill>
@@ -3834,7 +3774,7 @@
               <a:t>• </a:t>
             </a:r>
             <a:r>
-              <a:rPr lang="zh-TW" altLang="en-US" sz="1060">
+              <a:rPr lang="zh-TW" altLang="en-US" sz="1020">
                 <a:solidFill>
                   <a:srgbClr val="0E437D"/>
                 </a:solidFill>
@@ -3844,7 +3784,7 @@
 </a:t>
             </a:r>
             <a:r>
-              <a:rPr lang="en-US" altLang="zh-TW" sz="1060">
+              <a:rPr lang="en-US" altLang="zh-TW" sz="1020">
                 <a:solidFill>
                   <a:srgbClr val="0E437D"/>
                 </a:solidFill>
@@ -3853,13 +3793,13 @@
               <a:t>• </a:t>
             </a:r>
             <a:r>
-              <a:rPr lang="zh-TW" altLang="en-US" sz="1060">
+              <a:rPr lang="zh-TW" altLang="en-US" sz="1020">
                 <a:solidFill>
                   <a:srgbClr val="0E437D"/>
                 </a:solidFill>
                 <a:latin typeface="Microsoft JhengHei" panose="020B0604030504040204" pitchFamily="34" charset="-120"/>
               </a:rPr>
-              <a:t>不替使用者做決定</a:t>
+              <a:t>不替使用者做最終決定</a:t>
             </a:r>
           </a:p>
         </p:txBody>
@@ -3867,7 +3807,7 @@
     </p:spTree>
     <p:extLst>
       <p:ext uri="{BB962C8B-B14F-4D97-AF65-F5344CB8AC3E}">
-        <p14:creationId xmlns:p14="http://schemas.microsoft.com/office/powerpoint/2010/main" val="1750114381"/>
+        <p14:creationId xmlns:p14="http://schemas.microsoft.com/office/powerpoint/2010/main" val="3296210675"/>
       </p:ext>
     </p:extLst>
   </p:cSld>

</xml_diff>